<commit_message>
WIP(lectures): fix QA issues in lecture 02 slides and add QA tooling
- Fix text clipping on slides 01, 05 by increasing line-height from 0.9/0.95 to 1.0/1.05
- Reduce font-size from 38pt to 34pt on slide 06 to prevent orphan line break
- Add word-break: keep-all on slide 03 to fix Korean text wrapping
- Add justify-content: center on slide 10 right column for content balance
- Increase sub-10px badge labels to 8pt minimum across slides 01, 03, 11
- Add QA scripts (qa-screenshot.cjs, qa-deep-check.cjs) and screenshots
- Add comprehensive QA-REPORT.md with 11 findings across all slides
- Update PPTX binary with applied fixes
</commit_message>
<xml_diff>
--- a/lectures/02_ai_skills/AI대체불가Skills_v6_impeccable.pptx
+++ b/lectures/02_ai_skills/AI대체불가Skills_v6_impeccable.pptx
@@ -1803,24 +1803,24 @@
         </p:nvSpPr>
         <p:spPr>
           <a:xfrm>
-            <a:off x="252413" y="1616273"/>
-            <a:ext cx="111062" cy="1910953"/>
-          </a:xfrm>
-          <a:prstGeom prst="rect">
-            <a:avLst/>
-          </a:prstGeom>
-          <a:noFill/>
-          <a:ln/>
-        </p:spPr>
-        <p:txBody>
-          <a:bodyPr wrap="square" lIns="0" tIns="0" rIns="0" bIns="0" rtlCol="0" anchor="t"/>
-          <a:lstStyle/>
-          <a:p>
-            <a:pPr algn="l" indent="0" marL="0">
-              <a:buNone/>
-            </a:pPr>
-            <a:r>
-              <a:rPr lang="en-US" sz="700" b="1" dirty="0">
+            <a:off x="247650" y="1489918"/>
+            <a:ext cx="121158" cy="2163663"/>
+          </a:xfrm>
+          <a:prstGeom prst="rect">
+            <a:avLst/>
+          </a:prstGeom>
+          <a:noFill/>
+          <a:ln/>
+        </p:spPr>
+        <p:txBody>
+          <a:bodyPr wrap="square" lIns="0" tIns="0" rIns="0" bIns="0" rtlCol="0" anchor="t"/>
+          <a:lstStyle/>
+          <a:p>
+            <a:pPr algn="l" indent="0" marL="0">
+              <a:buNone/>
+            </a:pPr>
+            <a:r>
+              <a:rPr lang="en-US" sz="800" b="1" dirty="0">
                 <a:solidFill>
                   <a:srgbClr val="666666"/>
                 </a:solidFill>
@@ -1830,7 +1830,7 @@
               </a:rPr>
               <a:t>BNI K-CHAPTER · AI 시대 네트워킹 #2</a:t>
             </a:r>
-            <a:endParaRPr lang="en-US" sz="700" dirty="0"/>
+            <a:endParaRPr lang="en-US" sz="800" dirty="0"/>
           </a:p>
         </p:txBody>
       </p:sp>
@@ -1881,8 +1881,8 @@
         </p:nvSpPr>
         <p:spPr>
           <a:xfrm>
-            <a:off x="1269950" y="1599307"/>
-            <a:ext cx="4954226" cy="916781"/>
+            <a:off x="1269950" y="1502718"/>
+            <a:ext cx="4954226" cy="1013371"/>
           </a:xfrm>
           <a:prstGeom prst="rect">
             <a:avLst/>
@@ -1896,7 +1896,7 @@
           <a:p>
             <a:pPr algn="l" indent="0" marL="0">
               <a:lnSpc>
-                <a:spcPts val="7220"/>
+                <a:spcPts val="7980"/>
               </a:lnSpc>
               <a:buNone/>
             </a:pPr>
@@ -1924,7 +1924,7 @@
         <p:spPr>
           <a:xfrm>
             <a:off x="1269950" y="2516088"/>
-            <a:ext cx="4954226" cy="916781"/>
+            <a:ext cx="4954226" cy="1013371"/>
           </a:xfrm>
           <a:prstGeom prst="rect">
             <a:avLst/>
@@ -1938,7 +1938,7 @@
           <a:p>
             <a:pPr algn="l" indent="0" marL="0">
               <a:lnSpc>
-                <a:spcPts val="7220"/>
+                <a:spcPts val="7980"/>
               </a:lnSpc>
               <a:buNone/>
             </a:pPr>
@@ -1965,7 +1965,7 @@
         </p:nvSpPr>
         <p:spPr>
           <a:xfrm>
-            <a:off x="1269950" y="3737670"/>
+            <a:off x="1269950" y="3834259"/>
             <a:ext cx="711101" cy="38100"/>
           </a:xfrm>
           <a:prstGeom prst="rect">
@@ -2177,7 +2177,7 @@
         </p:nvSpPr>
         <p:spPr>
           <a:xfrm>
-            <a:off x="0" y="553938"/>
+            <a:off x="0" y="544413"/>
             <a:ext cx="9144000" cy="0"/>
           </a:xfrm>
           <a:prstGeom prst="line">
@@ -2201,7 +2201,7 @@
         <p:spPr>
           <a:xfrm>
             <a:off x="660350" y="203150"/>
-            <a:ext cx="8292697" cy="142875"/>
+            <a:ext cx="8292697" cy="133350"/>
           </a:xfrm>
           <a:prstGeom prst="rect">
             <a:avLst/>
@@ -2239,8 +2239,8 @@
         </p:nvSpPr>
         <p:spPr>
           <a:xfrm>
-            <a:off x="0" y="558701"/>
-            <a:ext cx="3403550" cy="4584799"/>
+            <a:off x="0" y="549176"/>
+            <a:ext cx="3403550" cy="4594324"/>
           </a:xfrm>
           <a:prstGeom prst="rect">
             <a:avLst/>
@@ -2269,8 +2269,8 @@
         </p:nvSpPr>
         <p:spPr>
           <a:xfrm>
-            <a:off x="3398788" y="558701"/>
-            <a:ext cx="0" cy="4584799"/>
+            <a:off x="3398788" y="549176"/>
+            <a:ext cx="0" cy="4594324"/>
           </a:xfrm>
           <a:prstGeom prst="line">
             <a:avLst/>
@@ -2292,8 +2292,8 @@
         </p:nvSpPr>
         <p:spPr>
           <a:xfrm>
-            <a:off x="406301" y="914251"/>
-            <a:ext cx="2736309" cy="114300"/>
+            <a:off x="406301" y="904726"/>
+            <a:ext cx="2736309" cy="123825"/>
           </a:xfrm>
           <a:prstGeom prst="rect">
             <a:avLst/>
@@ -2448,8 +2448,8 @@
         </p:nvSpPr>
         <p:spPr>
           <a:xfrm>
-            <a:off x="3403550" y="558701"/>
-            <a:ext cx="5740450" cy="4584799"/>
+            <a:off x="3403550" y="549176"/>
+            <a:ext cx="5740450" cy="4594324"/>
           </a:xfrm>
           <a:prstGeom prst="rect">
             <a:avLst/>
@@ -2478,8 +2478,8 @@
         </p:nvSpPr>
         <p:spPr>
           <a:xfrm>
-            <a:off x="3422600" y="558701"/>
-            <a:ext cx="0" cy="4584799"/>
+            <a:off x="3422600" y="549176"/>
+            <a:ext cx="0" cy="4594324"/>
           </a:xfrm>
           <a:prstGeom prst="line">
             <a:avLst/>
@@ -2501,8 +2501,8 @@
         </p:nvSpPr>
         <p:spPr>
           <a:xfrm>
-            <a:off x="3949601" y="914251"/>
-            <a:ext cx="4967636" cy="114300"/>
+            <a:off x="3949601" y="2082850"/>
+            <a:ext cx="4967636" cy="123825"/>
           </a:xfrm>
           <a:prstGeom prst="rect">
             <a:avLst/>
@@ -2543,7 +2543,7 @@
         </p:nvSpPr>
         <p:spPr>
           <a:xfrm>
-            <a:off x="3949601" y="1130052"/>
+            <a:off x="3949601" y="2308175"/>
             <a:ext cx="355550" cy="25301"/>
           </a:xfrm>
           <a:prstGeom prst="rect">
@@ -2968,7 +2968,7 @@
         </p:nvSpPr>
         <p:spPr>
           <a:xfrm>
-            <a:off x="914400" y="1921966"/>
+            <a:off x="914400" y="1917204"/>
             <a:ext cx="7315200" cy="12650"/>
           </a:xfrm>
           <a:prstGeom prst="rect">
@@ -2998,8 +2998,8 @@
         </p:nvSpPr>
         <p:spPr>
           <a:xfrm>
-            <a:off x="914400" y="2821632"/>
-            <a:ext cx="973634" cy="206276"/>
+            <a:off x="914400" y="2812107"/>
+            <a:ext cx="1062038" cy="215801"/>
           </a:xfrm>
           <a:prstGeom prst="rect">
             <a:avLst/>
@@ -3028,24 +3028,24 @@
         </p:nvSpPr>
         <p:spPr>
           <a:xfrm>
-            <a:off x="1066800" y="2872383"/>
-            <a:ext cx="708964" cy="104775"/>
-          </a:xfrm>
-          <a:prstGeom prst="rect">
-            <a:avLst/>
-          </a:prstGeom>
-          <a:noFill/>
-          <a:ln/>
-        </p:spPr>
-        <p:txBody>
-          <a:bodyPr wrap="square" lIns="0" tIns="0" rIns="0" bIns="0" rtlCol="0" anchor="t"/>
-          <a:lstStyle/>
-          <a:p>
-            <a:pPr algn="l" indent="0" marL="0">
-              <a:buNone/>
-            </a:pPr>
-            <a:r>
-              <a:rPr lang="en-US" sz="700" b="1" dirty="0">
+            <a:off x="1066800" y="2862858"/>
+            <a:ext cx="802672" cy="114300"/>
+          </a:xfrm>
+          <a:prstGeom prst="rect">
+            <a:avLst/>
+          </a:prstGeom>
+          <a:noFill/>
+          <a:ln/>
+        </p:spPr>
+        <p:txBody>
+          <a:bodyPr wrap="square" lIns="0" tIns="0" rIns="0" bIns="0" rtlCol="0" anchor="t"/>
+          <a:lstStyle/>
+          <a:p>
+            <a:pPr algn="l" indent="0" marL="0">
+              <a:buNone/>
+            </a:pPr>
+            <a:r>
+              <a:rPr lang="en-US" sz="800" b="1" dirty="0">
                 <a:solidFill>
                   <a:srgbClr val="FFFFFF"/>
                 </a:solidFill>
@@ -3055,7 +3055,7 @@
               </a:rPr>
               <a:t>HOMEWORK</a:t>
             </a:r>
-            <a:endParaRPr lang="en-US" sz="700" dirty="0"/>
+            <a:endParaRPr lang="en-US" sz="800" dirty="0"/>
           </a:p>
         </p:txBody>
       </p:sp>
@@ -3498,8 +3498,8 @@
         </p:nvSpPr>
         <p:spPr>
           <a:xfrm>
-            <a:off x="1091952" y="615851"/>
-            <a:ext cx="996083" cy="104775"/>
+            <a:off x="1091952" y="601563"/>
+            <a:ext cx="948913" cy="123825"/>
           </a:xfrm>
           <a:prstGeom prst="rect">
             <a:avLst/>
@@ -3518,7 +3518,7 @@
               <a:buNone/>
             </a:pPr>
             <a:r>
-              <a:rPr lang="en-US" sz="700" b="1" dirty="0">
+              <a:rPr lang="en-US" sz="800" b="1" dirty="0">
                 <a:solidFill>
                   <a:srgbClr val="999999"/>
                 </a:solidFill>
@@ -3528,7 +3528,7 @@
               </a:rPr>
               <a:t>ANTHROPIC</a:t>
             </a:r>
-            <a:endParaRPr lang="en-US" sz="700" dirty="0"/>
+            <a:endParaRPr lang="en-US" sz="800" dirty="0"/>
           </a:p>
         </p:txBody>
       </p:sp>
@@ -3540,8 +3540,8 @@
         </p:nvSpPr>
         <p:spPr>
           <a:xfrm>
-            <a:off x="1091952" y="745927"/>
-            <a:ext cx="996083" cy="161925"/>
+            <a:off x="1091952" y="750689"/>
+            <a:ext cx="948913" cy="171450"/>
           </a:xfrm>
           <a:prstGeom prst="rect">
             <a:avLst/>
@@ -3705,8 +3705,8 @@
         </p:nvSpPr>
         <p:spPr>
           <a:xfrm>
-            <a:off x="3352651" y="1581894"/>
-            <a:ext cx="5492654" cy="161925"/>
+            <a:off x="3352651" y="1577132"/>
+            <a:ext cx="5492654" cy="171450"/>
           </a:xfrm>
           <a:prstGeom prst="rect">
             <a:avLst/>
@@ -3747,7 +3747,7 @@
         </p:nvSpPr>
         <p:spPr>
           <a:xfrm>
-            <a:off x="3352651" y="1896219"/>
+            <a:off x="3352651" y="1900982"/>
             <a:ext cx="5492654" cy="554980"/>
           </a:xfrm>
           <a:prstGeom prst="rect">
@@ -3789,7 +3789,7 @@
         </p:nvSpPr>
         <p:spPr>
           <a:xfrm>
-            <a:off x="3352651" y="2451199"/>
+            <a:off x="3352651" y="2455962"/>
             <a:ext cx="5492654" cy="554980"/>
           </a:xfrm>
           <a:prstGeom prst="rect">
@@ -3977,8 +3977,8 @@
         </p:nvSpPr>
         <p:spPr>
           <a:xfrm>
-            <a:off x="1015901" y="1950839"/>
-            <a:ext cx="7538930" cy="533400"/>
+            <a:off x="1015901" y="1879848"/>
+            <a:ext cx="7538930" cy="604391"/>
           </a:xfrm>
           <a:prstGeom prst="rect">
             <a:avLst/>
@@ -3992,12 +3992,12 @@
           <a:p>
             <a:pPr algn="l" indent="0" marL="0">
               <a:lnSpc>
-                <a:spcPts val="4200"/>
+                <a:spcPts val="4760"/>
               </a:lnSpc>
               <a:buNone/>
             </a:pPr>
             <a:r>
-              <a:rPr lang="en-US" sz="3000" b="1" dirty="0">
+              <a:rPr lang="en-US" sz="3400" b="1" dirty="0">
                 <a:solidFill>
                   <a:srgbClr val="1A1A1A"/>
                 </a:solidFill>
@@ -4007,7 +4007,7 @@
               </a:rPr>
               <a:t>잘해서 자르는 게 아니라,</a:t>
             </a:r>
-            <a:endParaRPr lang="en-US" sz="3000" dirty="0"/>
+            <a:endParaRPr lang="en-US" sz="3400" dirty="0"/>
           </a:p>
         </p:txBody>
       </p:sp>
@@ -4020,7 +4020,7 @@
         <p:spPr>
           <a:xfrm>
             <a:off x="1015901" y="2484239"/>
-            <a:ext cx="7538930" cy="533400"/>
+            <a:ext cx="7538930" cy="604391"/>
           </a:xfrm>
           <a:prstGeom prst="rect">
             <a:avLst/>
@@ -4034,12 +4034,12 @@
           <a:p>
             <a:pPr algn="l" indent="0" marL="0">
               <a:lnSpc>
-                <a:spcPts val="4200"/>
+                <a:spcPts val="4760"/>
               </a:lnSpc>
               <a:buNone/>
             </a:pPr>
             <a:r>
-              <a:rPr lang="en-US" sz="3000" b="1" dirty="0">
+              <a:rPr lang="en-US" sz="3400" b="1" dirty="0">
                 <a:solidFill>
                   <a:srgbClr val="1A1A1A"/>
                 </a:solidFill>
@@ -4049,7 +4049,7 @@
               </a:rPr>
               <a:t>잘할 것 같아서 자르고 있다</a:t>
             </a:r>
-            <a:endParaRPr lang="en-US" sz="3000" dirty="0"/>
+            <a:endParaRPr lang="en-US" sz="3400" dirty="0"/>
           </a:p>
         </p:txBody>
       </p:sp>
@@ -4061,7 +4061,7 @@
         </p:nvSpPr>
         <p:spPr>
           <a:xfrm>
-            <a:off x="1015901" y="3220789"/>
+            <a:off x="1015901" y="3291780"/>
             <a:ext cx="7538930" cy="152400"/>
           </a:xfrm>
           <a:prstGeom prst="rect">
@@ -4296,8 +4296,8 @@
         </p:nvSpPr>
         <p:spPr>
           <a:xfrm>
-            <a:off x="1092101" y="639663"/>
-            <a:ext cx="1307812" cy="142875"/>
+            <a:off x="1092101" y="644426"/>
+            <a:ext cx="1244078" cy="133350"/>
           </a:xfrm>
           <a:prstGeom prst="rect">
             <a:avLst/>
@@ -4335,7 +4335,7 @@
         </p:nvSpPr>
         <p:spPr>
           <a:xfrm>
-            <a:off x="660350" y="1843980"/>
+            <a:off x="660350" y="1782961"/>
             <a:ext cx="3597825" cy="152400"/>
           </a:xfrm>
           <a:prstGeom prst="rect">
@@ -4377,8 +4377,8 @@
         </p:nvSpPr>
         <p:spPr>
           <a:xfrm>
-            <a:off x="660350" y="2047131"/>
-            <a:ext cx="3597825" cy="1097161"/>
+            <a:off x="660350" y="1986111"/>
+            <a:ext cx="3597825" cy="1219200"/>
           </a:xfrm>
           <a:prstGeom prst="rect">
             <a:avLst/>
@@ -4392,7 +4392,7 @@
           <a:p>
             <a:pPr algn="l" indent="0" marL="0">
               <a:lnSpc>
-                <a:spcPts val="8640"/>
+                <a:spcPts val="9600"/>
               </a:lnSpc>
               <a:buNone/>
             </a:pPr>
@@ -4484,8 +4484,8 @@
         </p:nvSpPr>
         <p:spPr>
           <a:xfrm>
-            <a:off x="5181600" y="730746"/>
-            <a:ext cx="3553968" cy="142875"/>
+            <a:off x="5181600" y="711696"/>
+            <a:ext cx="3553968" cy="133350"/>
           </a:xfrm>
           <a:prstGeom prst="rect">
             <a:avLst/>
@@ -4526,8 +4526,8 @@
         </p:nvSpPr>
         <p:spPr>
           <a:xfrm>
-            <a:off x="5181600" y="1178421"/>
-            <a:ext cx="3352800" cy="752177"/>
+            <a:off x="5181600" y="1149846"/>
+            <a:ext cx="3352800" cy="761702"/>
           </a:xfrm>
           <a:prstGeom prst="rect">
             <a:avLst/>
@@ -4556,8 +4556,8 @@
         </p:nvSpPr>
         <p:spPr>
           <a:xfrm>
-            <a:off x="5435501" y="1356122"/>
-            <a:ext cx="3015698" cy="219075"/>
+            <a:off x="5435501" y="1327547"/>
+            <a:ext cx="3015698" cy="228600"/>
           </a:xfrm>
           <a:prstGeom prst="rect">
             <a:avLst/>
@@ -4595,7 +4595,7 @@
         </p:nvSpPr>
         <p:spPr>
           <a:xfrm>
-            <a:off x="5435501" y="1600498"/>
+            <a:off x="5435501" y="1581448"/>
             <a:ext cx="3015698" cy="152400"/>
           </a:xfrm>
           <a:prstGeom prst="rect">
@@ -4637,8 +4637,8 @@
         </p:nvSpPr>
         <p:spPr>
           <a:xfrm>
-            <a:off x="5435501" y="2057549"/>
-            <a:ext cx="3015698" cy="323850"/>
+            <a:off x="5435501" y="2038499"/>
+            <a:ext cx="3015698" cy="333375"/>
           </a:xfrm>
           <a:prstGeom prst="rect">
             <a:avLst/>
@@ -4676,8 +4676,8 @@
         </p:nvSpPr>
         <p:spPr>
           <a:xfrm>
-            <a:off x="5181600" y="2508349"/>
-            <a:ext cx="3352800" cy="752177"/>
+            <a:off x="5181600" y="2498824"/>
+            <a:ext cx="3352800" cy="761702"/>
           </a:xfrm>
           <a:prstGeom prst="rect">
             <a:avLst/>
@@ -4706,8 +4706,8 @@
         </p:nvSpPr>
         <p:spPr>
           <a:xfrm>
-            <a:off x="5435501" y="2686050"/>
-            <a:ext cx="3015698" cy="219075"/>
+            <a:off x="5435501" y="2676525"/>
+            <a:ext cx="3015698" cy="228600"/>
           </a:xfrm>
           <a:prstGeom prst="rect">
             <a:avLst/>
@@ -4788,7 +4788,7 @@
         <p:spPr>
           <a:xfrm>
             <a:off x="5435501" y="3387477"/>
-            <a:ext cx="3015698" cy="323850"/>
+            <a:ext cx="3015698" cy="333375"/>
           </a:xfrm>
           <a:prstGeom prst="rect">
             <a:avLst/>
@@ -4826,8 +4826,8 @@
         </p:nvSpPr>
         <p:spPr>
           <a:xfrm>
-            <a:off x="5181600" y="3838277"/>
-            <a:ext cx="3352800" cy="574477"/>
+            <a:off x="5181600" y="3847802"/>
+            <a:ext cx="3352800" cy="584002"/>
           </a:xfrm>
           <a:prstGeom prst="rect">
             <a:avLst/>
@@ -4856,8 +4856,8 @@
         </p:nvSpPr>
         <p:spPr>
           <a:xfrm>
-            <a:off x="5435501" y="4015978"/>
-            <a:ext cx="3015698" cy="219075"/>
+            <a:off x="5435501" y="4025503"/>
+            <a:ext cx="3015698" cy="228600"/>
           </a:xfrm>
           <a:prstGeom prst="rect">
             <a:avLst/>
@@ -4993,7 +4993,7 @@
         <p:spPr>
           <a:xfrm>
             <a:off x="812750" y="1079450"/>
-            <a:ext cx="3732392" cy="1158180"/>
+            <a:ext cx="3732392" cy="518071"/>
           </a:xfrm>
           <a:prstGeom prst="rect">
             <a:avLst/>
@@ -5007,12 +5007,12 @@
           <a:p>
             <a:pPr algn="l" indent="0" marL="0">
               <a:lnSpc>
-                <a:spcPts val="4560"/>
+                <a:spcPts val="4080"/>
               </a:lnSpc>
               <a:buNone/>
             </a:pPr>
             <a:r>
-              <a:rPr lang="en-US" sz="3800" b="1" dirty="0">
+              <a:rPr lang="en-US" sz="3400" b="1" dirty="0">
                 <a:solidFill>
                   <a:srgbClr val="FFFFFF"/>
                 </a:solidFill>
@@ -5022,7 +5022,7 @@
               </a:rPr>
               <a:t>AI가 따라올 수 없는</a:t>
             </a:r>
-            <a:endParaRPr lang="en-US" sz="3800" dirty="0"/>
+            <a:endParaRPr lang="en-US" sz="3400" dirty="0"/>
           </a:p>
         </p:txBody>
       </p:sp>
@@ -5034,8 +5034,8 @@
         </p:nvSpPr>
         <p:spPr>
           <a:xfrm>
-            <a:off x="812750" y="2237631"/>
-            <a:ext cx="3732392" cy="579090"/>
+            <a:off x="812750" y="1597521"/>
+            <a:ext cx="3732392" cy="518071"/>
           </a:xfrm>
           <a:prstGeom prst="rect">
             <a:avLst/>
@@ -5049,12 +5049,12 @@
           <a:p>
             <a:pPr algn="l" indent="0" marL="0">
               <a:lnSpc>
-                <a:spcPts val="4560"/>
+                <a:spcPts val="4080"/>
               </a:lnSpc>
               <a:buNone/>
             </a:pPr>
             <a:r>
-              <a:rPr lang="en-US" sz="3800" b="1" dirty="0">
+              <a:rPr lang="en-US" sz="3400" b="1" dirty="0">
                 <a:solidFill>
                   <a:srgbClr val="FFFFFF"/>
                 </a:solidFill>
@@ -5064,7 +5064,7 @@
               </a:rPr>
               <a:t>세 가지 판단력</a:t>
             </a:r>
-            <a:endParaRPr lang="en-US" sz="3800" dirty="0"/>
+            <a:endParaRPr lang="en-US" sz="3400" dirty="0"/>
           </a:p>
         </p:txBody>
       </p:sp>
@@ -6113,8 +6113,8 @@
         </p:nvSpPr>
         <p:spPr>
           <a:xfrm>
-            <a:off x="812750" y="670768"/>
-            <a:ext cx="812453" cy="250627"/>
+            <a:off x="812750" y="675531"/>
+            <a:ext cx="848469" cy="241102"/>
           </a:xfrm>
           <a:prstGeom prst="rect">
             <a:avLst/>
@@ -6143,8 +6143,8 @@
         </p:nvSpPr>
         <p:spPr>
           <a:xfrm>
-            <a:off x="990451" y="734169"/>
-            <a:ext cx="484474" cy="123825"/>
+            <a:off x="990451" y="738932"/>
+            <a:ext cx="522652" cy="114300"/>
           </a:xfrm>
           <a:prstGeom prst="rect">
             <a:avLst/>
@@ -6182,8 +6182,8 @@
         </p:nvSpPr>
         <p:spPr>
           <a:xfrm>
-            <a:off x="1828354" y="558701"/>
-            <a:ext cx="1997845" cy="474911"/>
+            <a:off x="1864370" y="558701"/>
+            <a:ext cx="1990115" cy="474911"/>
           </a:xfrm>
           <a:prstGeom prst="rect">
             <a:avLst/>
@@ -6297,7 +6297,7 @@
         <p:spPr>
           <a:xfrm>
             <a:off x="812750" y="4006007"/>
-            <a:ext cx="2722584" cy="314771"/>
+            <a:ext cx="2714854" cy="314771"/>
           </a:xfrm>
           <a:prstGeom prst="rect">
             <a:avLst/>
@@ -6339,7 +6339,7 @@
         <p:spPr>
           <a:xfrm>
             <a:off x="812750" y="4320778"/>
-            <a:ext cx="2722584" cy="314771"/>
+            <a:ext cx="2714854" cy="314771"/>
           </a:xfrm>
           <a:prstGeom prst="rect">
             <a:avLst/>

</xml_diff>

<commit_message>
WIP(lectures): add word-break keep-all to all lecture 02 slides
- Add word-break: keep-all to body style on slides 01-11 for Korean text wrapping
- Adjust slide-05 hero number size from 96pt to 80pt and increase spacing
- Rebuild PPTX with updated slide styles
</commit_message>
<xml_diff>
--- a/lectures/02_ai_skills/AI대체불가Skills_v6_impeccable.pptx
+++ b/lectures/02_ai_skills/AI대체불가Skills_v6_impeccable.pptx
@@ -2177,7 +2177,7 @@
         </p:nvSpPr>
         <p:spPr>
           <a:xfrm>
-            <a:off x="0" y="544413"/>
+            <a:off x="0" y="553938"/>
             <a:ext cx="9144000" cy="0"/>
           </a:xfrm>
           <a:prstGeom prst="line">
@@ -2201,7 +2201,7 @@
         <p:spPr>
           <a:xfrm>
             <a:off x="660350" y="203150"/>
-            <a:ext cx="8292697" cy="133350"/>
+            <a:ext cx="8292697" cy="142875"/>
           </a:xfrm>
           <a:prstGeom prst="rect">
             <a:avLst/>
@@ -2239,8 +2239,8 @@
         </p:nvSpPr>
         <p:spPr>
           <a:xfrm>
-            <a:off x="0" y="549176"/>
-            <a:ext cx="3403550" cy="4594324"/>
+            <a:off x="0" y="558701"/>
+            <a:ext cx="3403550" cy="4584799"/>
           </a:xfrm>
           <a:prstGeom prst="rect">
             <a:avLst/>
@@ -2269,8 +2269,8 @@
         </p:nvSpPr>
         <p:spPr>
           <a:xfrm>
-            <a:off x="3398788" y="549176"/>
-            <a:ext cx="0" cy="4594324"/>
+            <a:off x="3398788" y="558701"/>
+            <a:ext cx="0" cy="4584799"/>
           </a:xfrm>
           <a:prstGeom prst="line">
             <a:avLst/>
@@ -2292,8 +2292,8 @@
         </p:nvSpPr>
         <p:spPr>
           <a:xfrm>
-            <a:off x="406301" y="904726"/>
-            <a:ext cx="2736309" cy="123825"/>
+            <a:off x="406301" y="914251"/>
+            <a:ext cx="2736309" cy="114300"/>
           </a:xfrm>
           <a:prstGeom prst="rect">
             <a:avLst/>
@@ -2448,8 +2448,8 @@
         </p:nvSpPr>
         <p:spPr>
           <a:xfrm>
-            <a:off x="3403550" y="549176"/>
-            <a:ext cx="5740450" cy="4594324"/>
+            <a:off x="3403550" y="558701"/>
+            <a:ext cx="5740450" cy="4584799"/>
           </a:xfrm>
           <a:prstGeom prst="rect">
             <a:avLst/>
@@ -2478,8 +2478,8 @@
         </p:nvSpPr>
         <p:spPr>
           <a:xfrm>
-            <a:off x="3422600" y="549176"/>
-            <a:ext cx="0" cy="4594324"/>
+            <a:off x="3422600" y="558701"/>
+            <a:ext cx="0" cy="4584799"/>
           </a:xfrm>
           <a:prstGeom prst="line">
             <a:avLst/>
@@ -2501,8 +2501,8 @@
         </p:nvSpPr>
         <p:spPr>
           <a:xfrm>
-            <a:off x="3949601" y="2082850"/>
-            <a:ext cx="4967636" cy="123825"/>
+            <a:off x="3949601" y="2092375"/>
+            <a:ext cx="4967636" cy="114300"/>
           </a:xfrm>
           <a:prstGeom prst="rect">
             <a:avLst/>
@@ -2732,7 +2732,7 @@
         <p:spPr>
           <a:xfrm>
             <a:off x="914400" y="558701"/>
-            <a:ext cx="7754112" cy="114300"/>
+            <a:ext cx="7754112" cy="123825"/>
           </a:xfrm>
           <a:prstGeom prst="rect">
             <a:avLst/>
@@ -2773,8 +2773,8 @@
         </p:nvSpPr>
         <p:spPr>
           <a:xfrm>
-            <a:off x="914400" y="825401"/>
-            <a:ext cx="1054926" cy="209550"/>
+            <a:off x="914400" y="834926"/>
+            <a:ext cx="1053980" cy="219075"/>
           </a:xfrm>
           <a:prstGeom prst="rect">
             <a:avLst/>
@@ -2812,8 +2812,8 @@
         </p:nvSpPr>
         <p:spPr>
           <a:xfrm>
-            <a:off x="1909614" y="825401"/>
-            <a:ext cx="372466" cy="209550"/>
+            <a:off x="1908721" y="834926"/>
+            <a:ext cx="369311" cy="219075"/>
           </a:xfrm>
           <a:prstGeom prst="rect">
             <a:avLst/>
@@ -2851,8 +2851,8 @@
         </p:nvSpPr>
         <p:spPr>
           <a:xfrm>
-            <a:off x="2260997" y="825401"/>
-            <a:ext cx="1538139" cy="209550"/>
+            <a:off x="2257127" y="834926"/>
+            <a:ext cx="1536719" cy="219075"/>
           </a:xfrm>
           <a:prstGeom prst="rect">
             <a:avLst/>
@@ -2890,8 +2890,8 @@
         </p:nvSpPr>
         <p:spPr>
           <a:xfrm>
-            <a:off x="3712071" y="825401"/>
-            <a:ext cx="372466" cy="209550"/>
+            <a:off x="3706862" y="834926"/>
+            <a:ext cx="369311" cy="219075"/>
           </a:xfrm>
           <a:prstGeom prst="rect">
             <a:avLst/>
@@ -2929,8 +2929,8 @@
         </p:nvSpPr>
         <p:spPr>
           <a:xfrm>
-            <a:off x="4063454" y="825401"/>
-            <a:ext cx="1215997" cy="209550"/>
+            <a:off x="4055269" y="834926"/>
+            <a:ext cx="1214893" cy="219075"/>
           </a:xfrm>
           <a:prstGeom prst="rect">
             <a:avLst/>
@@ -2968,7 +2968,7 @@
         </p:nvSpPr>
         <p:spPr>
           <a:xfrm>
-            <a:off x="914400" y="1917204"/>
+            <a:off x="914400" y="1921966"/>
             <a:ext cx="7315200" cy="12650"/>
           </a:xfrm>
           <a:prstGeom prst="rect">
@@ -2998,8 +2998,8 @@
         </p:nvSpPr>
         <p:spPr>
           <a:xfrm>
-            <a:off x="914400" y="2812107"/>
-            <a:ext cx="1062038" cy="215801"/>
+            <a:off x="914400" y="2802582"/>
+            <a:ext cx="1023045" cy="225326"/>
           </a:xfrm>
           <a:prstGeom prst="rect">
             <a:avLst/>
@@ -3028,8 +3028,8 @@
         </p:nvSpPr>
         <p:spPr>
           <a:xfrm>
-            <a:off x="1066800" y="2862858"/>
-            <a:ext cx="802672" cy="114300"/>
+            <a:off x="1066800" y="2853333"/>
+            <a:ext cx="761339" cy="123825"/>
           </a:xfrm>
           <a:prstGeom prst="rect">
             <a:avLst/>
@@ -3498,8 +3498,8 @@
         </p:nvSpPr>
         <p:spPr>
           <a:xfrm>
-            <a:off x="1091952" y="601563"/>
-            <a:ext cx="948913" cy="123825"/>
+            <a:off x="1091952" y="611088"/>
+            <a:ext cx="996083" cy="114300"/>
           </a:xfrm>
           <a:prstGeom prst="rect">
             <a:avLst/>
@@ -3541,7 +3541,7 @@
         <p:spPr>
           <a:xfrm>
             <a:off x="1091952" y="750689"/>
-            <a:ext cx="948913" cy="171450"/>
+            <a:ext cx="996083" cy="161925"/>
           </a:xfrm>
           <a:prstGeom prst="rect">
             <a:avLst/>
@@ -3705,8 +3705,8 @@
         </p:nvSpPr>
         <p:spPr>
           <a:xfrm>
-            <a:off x="3352651" y="1577132"/>
-            <a:ext cx="5492654" cy="171450"/>
+            <a:off x="3352651" y="1581894"/>
+            <a:ext cx="5492654" cy="161925"/>
           </a:xfrm>
           <a:prstGeom prst="rect">
             <a:avLst/>
@@ -3747,7 +3747,7 @@
         </p:nvSpPr>
         <p:spPr>
           <a:xfrm>
-            <a:off x="3352651" y="1900982"/>
+            <a:off x="3352651" y="1896219"/>
             <a:ext cx="5492654" cy="554980"/>
           </a:xfrm>
           <a:prstGeom prst="rect">
@@ -3789,7 +3789,7 @@
         </p:nvSpPr>
         <p:spPr>
           <a:xfrm>
-            <a:off x="3352651" y="2455962"/>
+            <a:off x="3352651" y="2451199"/>
             <a:ext cx="5492654" cy="554980"/>
           </a:xfrm>
           <a:prstGeom prst="rect">
@@ -4296,8 +4296,8 @@
         </p:nvSpPr>
         <p:spPr>
           <a:xfrm>
-            <a:off x="1092101" y="644426"/>
-            <a:ext cx="1244078" cy="133350"/>
+            <a:off x="1092101" y="639663"/>
+            <a:ext cx="1307812" cy="142875"/>
           </a:xfrm>
           <a:prstGeom prst="rect">
             <a:avLst/>
@@ -4335,7 +4335,7 @@
         </p:nvSpPr>
         <p:spPr>
           <a:xfrm>
-            <a:off x="660350" y="1782961"/>
+            <a:off x="660350" y="1757511"/>
             <a:ext cx="3597825" cy="152400"/>
           </a:xfrm>
           <a:prstGeom prst="rect">
@@ -4350,7 +4350,7 @@
           <a:p>
             <a:pPr algn="l" indent="0" marL="0">
               <a:spcAft>
-                <a:spcPts val="400"/>
+                <a:spcPts val="1600"/>
               </a:spcAft>
               <a:buNone/>
             </a:pPr>
@@ -4377,8 +4377,8 @@
         </p:nvSpPr>
         <p:spPr>
           <a:xfrm>
-            <a:off x="660350" y="1986111"/>
-            <a:ext cx="3597825" cy="1219200"/>
+            <a:off x="660350" y="2113062"/>
+            <a:ext cx="3597825" cy="1117550"/>
           </a:xfrm>
           <a:prstGeom prst="rect">
             <a:avLst/>
@@ -4392,12 +4392,12 @@
           <a:p>
             <a:pPr algn="l" indent="0" marL="0">
               <a:lnSpc>
-                <a:spcPts val="9600"/>
+                <a:spcPts val="8800"/>
               </a:lnSpc>
               <a:buNone/>
             </a:pPr>
             <a:r>
-              <a:rPr lang="en-US" sz="9600" b="1" dirty="0">
+              <a:rPr lang="en-US" sz="8000" b="1" dirty="0">
                 <a:solidFill>
                   <a:srgbClr val="1A1A1A"/>
                 </a:solidFill>
@@ -4407,7 +4407,7 @@
               </a:rPr>
               <a:t>2배</a:t>
             </a:r>
-            <a:endParaRPr lang="en-US" sz="9600" dirty="0"/>
+            <a:endParaRPr lang="en-US" sz="8000" dirty="0"/>
           </a:p>
         </p:txBody>
       </p:sp>
@@ -4484,8 +4484,8 @@
         </p:nvSpPr>
         <p:spPr>
           <a:xfrm>
-            <a:off x="5181600" y="711696"/>
-            <a:ext cx="3553968" cy="133350"/>
+            <a:off x="5181600" y="730746"/>
+            <a:ext cx="3553968" cy="142875"/>
           </a:xfrm>
           <a:prstGeom prst="rect">
             <a:avLst/>
@@ -4526,8 +4526,8 @@
         </p:nvSpPr>
         <p:spPr>
           <a:xfrm>
-            <a:off x="5181600" y="1149846"/>
-            <a:ext cx="3352800" cy="761702"/>
+            <a:off x="5181600" y="1178421"/>
+            <a:ext cx="3352800" cy="752177"/>
           </a:xfrm>
           <a:prstGeom prst="rect">
             <a:avLst/>
@@ -4556,8 +4556,8 @@
         </p:nvSpPr>
         <p:spPr>
           <a:xfrm>
-            <a:off x="5435501" y="1327547"/>
-            <a:ext cx="3015698" cy="228600"/>
+            <a:off x="5435501" y="1356122"/>
+            <a:ext cx="3015698" cy="219075"/>
           </a:xfrm>
           <a:prstGeom prst="rect">
             <a:avLst/>
@@ -4595,7 +4595,7 @@
         </p:nvSpPr>
         <p:spPr>
           <a:xfrm>
-            <a:off x="5435501" y="1581448"/>
+            <a:off x="5435501" y="1600498"/>
             <a:ext cx="3015698" cy="152400"/>
           </a:xfrm>
           <a:prstGeom prst="rect">
@@ -4637,8 +4637,8 @@
         </p:nvSpPr>
         <p:spPr>
           <a:xfrm>
-            <a:off x="5435501" y="2038499"/>
-            <a:ext cx="3015698" cy="333375"/>
+            <a:off x="5435501" y="2057549"/>
+            <a:ext cx="3015698" cy="323850"/>
           </a:xfrm>
           <a:prstGeom prst="rect">
             <a:avLst/>
@@ -4676,8 +4676,8 @@
         </p:nvSpPr>
         <p:spPr>
           <a:xfrm>
-            <a:off x="5181600" y="2498824"/>
-            <a:ext cx="3352800" cy="761702"/>
+            <a:off x="5181600" y="2508349"/>
+            <a:ext cx="3352800" cy="752177"/>
           </a:xfrm>
           <a:prstGeom prst="rect">
             <a:avLst/>
@@ -4706,8 +4706,8 @@
         </p:nvSpPr>
         <p:spPr>
           <a:xfrm>
-            <a:off x="5435501" y="2676525"/>
-            <a:ext cx="3015698" cy="228600"/>
+            <a:off x="5435501" y="2686050"/>
+            <a:ext cx="3015698" cy="219075"/>
           </a:xfrm>
           <a:prstGeom prst="rect">
             <a:avLst/>
@@ -4788,7 +4788,7 @@
         <p:spPr>
           <a:xfrm>
             <a:off x="5435501" y="3387477"/>
-            <a:ext cx="3015698" cy="333375"/>
+            <a:ext cx="3015698" cy="323850"/>
           </a:xfrm>
           <a:prstGeom prst="rect">
             <a:avLst/>
@@ -4826,8 +4826,8 @@
         </p:nvSpPr>
         <p:spPr>
           <a:xfrm>
-            <a:off x="5181600" y="3847802"/>
-            <a:ext cx="3352800" cy="584002"/>
+            <a:off x="5181600" y="3838277"/>
+            <a:ext cx="3352800" cy="574477"/>
           </a:xfrm>
           <a:prstGeom prst="rect">
             <a:avLst/>
@@ -4856,8 +4856,8 @@
         </p:nvSpPr>
         <p:spPr>
           <a:xfrm>
-            <a:off x="5435501" y="4025503"/>
-            <a:ext cx="3015698" cy="228600"/>
+            <a:off x="5435501" y="4015978"/>
+            <a:ext cx="3015698" cy="219075"/>
           </a:xfrm>
           <a:prstGeom prst="rect">
             <a:avLst/>

</xml_diff>

<commit_message>
WIP(lectures): separate badge and title layout in lecture 02 skill slides
- Split badge+title flex row into stacked badge and title blocks on slides 07-09
- Reduce title font size from 34pt to 26pt for better PPTX compatibility
- Change badge container from flex-shrink to inline-block display
- Update PPTX binary with regenerated slide layout
</commit_message>
<xml_diff>
--- a/lectures/02_ai_skills/AI대체불가Skills_v6_impeccable.pptx
+++ b/lectures/02_ai_skills/AI대체불가Skills_v6_impeccable.pptx
@@ -2177,7 +2177,7 @@
         </p:nvSpPr>
         <p:spPr>
           <a:xfrm>
-            <a:off x="0" y="553938"/>
+            <a:off x="0" y="544413"/>
             <a:ext cx="9144000" cy="0"/>
           </a:xfrm>
           <a:prstGeom prst="line">
@@ -2201,7 +2201,7 @@
         <p:spPr>
           <a:xfrm>
             <a:off x="660350" y="203150"/>
-            <a:ext cx="8292697" cy="142875"/>
+            <a:ext cx="8292697" cy="133350"/>
           </a:xfrm>
           <a:prstGeom prst="rect">
             <a:avLst/>
@@ -2239,8 +2239,8 @@
         </p:nvSpPr>
         <p:spPr>
           <a:xfrm>
-            <a:off x="0" y="558701"/>
-            <a:ext cx="3403550" cy="4584799"/>
+            <a:off x="0" y="549176"/>
+            <a:ext cx="3403550" cy="4594324"/>
           </a:xfrm>
           <a:prstGeom prst="rect">
             <a:avLst/>
@@ -2269,8 +2269,8 @@
         </p:nvSpPr>
         <p:spPr>
           <a:xfrm>
-            <a:off x="3398788" y="558701"/>
-            <a:ext cx="0" cy="4584799"/>
+            <a:off x="3398788" y="549176"/>
+            <a:ext cx="0" cy="4594324"/>
           </a:xfrm>
           <a:prstGeom prst="line">
             <a:avLst/>
@@ -2292,8 +2292,8 @@
         </p:nvSpPr>
         <p:spPr>
           <a:xfrm>
-            <a:off x="406301" y="914251"/>
-            <a:ext cx="2736309" cy="114300"/>
+            <a:off x="406301" y="904726"/>
+            <a:ext cx="2736309" cy="123825"/>
           </a:xfrm>
           <a:prstGeom prst="rect">
             <a:avLst/>
@@ -2448,8 +2448,8 @@
         </p:nvSpPr>
         <p:spPr>
           <a:xfrm>
-            <a:off x="3403550" y="558701"/>
-            <a:ext cx="5740450" cy="4584799"/>
+            <a:off x="3403550" y="549176"/>
+            <a:ext cx="5740450" cy="4594324"/>
           </a:xfrm>
           <a:prstGeom prst="rect">
             <a:avLst/>
@@ -2478,8 +2478,8 @@
         </p:nvSpPr>
         <p:spPr>
           <a:xfrm>
-            <a:off x="3422600" y="558701"/>
-            <a:ext cx="0" cy="4584799"/>
+            <a:off x="3422600" y="549176"/>
+            <a:ext cx="0" cy="4594324"/>
           </a:xfrm>
           <a:prstGeom prst="line">
             <a:avLst/>
@@ -2501,8 +2501,8 @@
         </p:nvSpPr>
         <p:spPr>
           <a:xfrm>
-            <a:off x="3949601" y="2092375"/>
-            <a:ext cx="4967636" cy="114300"/>
+            <a:off x="3949601" y="2082850"/>
+            <a:ext cx="4967636" cy="123825"/>
           </a:xfrm>
           <a:prstGeom prst="rect">
             <a:avLst/>
@@ -3498,8 +3498,8 @@
         </p:nvSpPr>
         <p:spPr>
           <a:xfrm>
-            <a:off x="1091952" y="611088"/>
-            <a:ext cx="996083" cy="114300"/>
+            <a:off x="1091952" y="601563"/>
+            <a:ext cx="948913" cy="123825"/>
           </a:xfrm>
           <a:prstGeom prst="rect">
             <a:avLst/>
@@ -3541,7 +3541,7 @@
         <p:spPr>
           <a:xfrm>
             <a:off x="1091952" y="750689"/>
-            <a:ext cx="996083" cy="161925"/>
+            <a:ext cx="948913" cy="171450"/>
           </a:xfrm>
           <a:prstGeom prst="rect">
             <a:avLst/>
@@ -3705,8 +3705,8 @@
         </p:nvSpPr>
         <p:spPr>
           <a:xfrm>
-            <a:off x="3352651" y="1581894"/>
-            <a:ext cx="5492654" cy="161925"/>
+            <a:off x="3352651" y="1577132"/>
+            <a:ext cx="5492654" cy="171450"/>
           </a:xfrm>
           <a:prstGeom prst="rect">
             <a:avLst/>
@@ -3747,7 +3747,7 @@
         </p:nvSpPr>
         <p:spPr>
           <a:xfrm>
-            <a:off x="3352651" y="1896219"/>
+            <a:off x="3352651" y="1900982"/>
             <a:ext cx="5492654" cy="554980"/>
           </a:xfrm>
           <a:prstGeom prst="rect">
@@ -3789,7 +3789,7 @@
         </p:nvSpPr>
         <p:spPr>
           <a:xfrm>
-            <a:off x="3352651" y="2451199"/>
+            <a:off x="3352651" y="2455962"/>
             <a:ext cx="5492654" cy="554980"/>
           </a:xfrm>
           <a:prstGeom prst="rect">
@@ -5427,7 +5427,7 @@
         </p:nvSpPr>
         <p:spPr>
           <a:xfrm>
-            <a:off x="812750" y="675531"/>
+            <a:off x="812750" y="558701"/>
             <a:ext cx="832396" cy="241102"/>
           </a:xfrm>
           <a:prstGeom prst="rect">
@@ -5457,7 +5457,7 @@
         </p:nvSpPr>
         <p:spPr>
           <a:xfrm>
-            <a:off x="990451" y="738932"/>
+            <a:off x="990451" y="622102"/>
             <a:ext cx="505614" cy="114300"/>
           </a:xfrm>
           <a:prstGeom prst="rect">
@@ -5496,8 +5496,8 @@
         </p:nvSpPr>
         <p:spPr>
           <a:xfrm>
-            <a:off x="1848296" y="558701"/>
-            <a:ext cx="2833804" cy="474911"/>
+            <a:off x="812750" y="926753"/>
+            <a:ext cx="7969609" cy="396180"/>
           </a:xfrm>
           <a:prstGeom prst="rect">
             <a:avLst/>
@@ -5511,12 +5511,15 @@
           <a:p>
             <a:pPr algn="l" indent="0" marL="0">
               <a:lnSpc>
-                <a:spcPts val="3740"/>
+                <a:spcPts val="3120"/>
               </a:lnSpc>
-              <a:buNone/>
-            </a:pPr>
-            <a:r>
-              <a:rPr lang="en-US" sz="3400" b="1" dirty="0">
+              <a:spcAft>
+                <a:spcPts val="2400"/>
+              </a:spcAft>
+              <a:buNone/>
+            </a:pPr>
+            <a:r>
+              <a:rPr lang="en-US" sz="2600" b="1" dirty="0">
                 <a:solidFill>
                   <a:srgbClr val="1A1A1A"/>
                 </a:solidFill>
@@ -5526,7 +5529,7 @@
               </a:rPr>
               <a:t>맥락을 읽는 판단</a:t>
             </a:r>
-            <a:endParaRPr lang="en-US" sz="3400" dirty="0"/>
+            <a:endParaRPr lang="en-US" sz="2600" dirty="0"/>
           </a:p>
         </p:txBody>
       </p:sp>
@@ -5538,7 +5541,7 @@
         </p:nvSpPr>
         <p:spPr>
           <a:xfrm>
-            <a:off x="812750" y="1389162"/>
+            <a:off x="812750" y="1627733"/>
             <a:ext cx="7518499" cy="1079599"/>
           </a:xfrm>
           <a:prstGeom prst="rect">
@@ -5568,7 +5571,7 @@
         </p:nvSpPr>
         <p:spPr>
           <a:xfrm>
-            <a:off x="836563" y="1389162"/>
+            <a:off x="836563" y="1627733"/>
             <a:ext cx="0" cy="1079599"/>
           </a:xfrm>
           <a:prstGeom prst="line">
@@ -5591,7 +5594,7 @@
         </p:nvSpPr>
         <p:spPr>
           <a:xfrm>
-            <a:off x="1165175" y="1617762"/>
+            <a:off x="1165175" y="1856333"/>
             <a:ext cx="7272951" cy="311200"/>
           </a:xfrm>
           <a:prstGeom prst="rect">
@@ -5633,7 +5636,7 @@
         </p:nvSpPr>
         <p:spPr>
           <a:xfrm>
-            <a:off x="1165175" y="1928961"/>
+            <a:off x="1165175" y="2167533"/>
             <a:ext cx="7272951" cy="311200"/>
           </a:xfrm>
           <a:prstGeom prst="rect">
@@ -5749,8 +5752,8 @@
         </p:nvSpPr>
         <p:spPr>
           <a:xfrm>
-            <a:off x="812750" y="675531"/>
-            <a:ext cx="845790" cy="241102"/>
+            <a:off x="812750" y="558701"/>
+            <a:ext cx="809476" cy="250627"/>
           </a:xfrm>
           <a:prstGeom prst="rect">
             <a:avLst/>
@@ -5779,8 +5782,8 @@
         </p:nvSpPr>
         <p:spPr>
           <a:xfrm>
-            <a:off x="990451" y="738932"/>
-            <a:ext cx="519812" cy="114300"/>
+            <a:off x="990451" y="622102"/>
+            <a:ext cx="481319" cy="123825"/>
           </a:xfrm>
           <a:prstGeom prst="rect">
             <a:avLst/>
@@ -5818,8 +5821,8 @@
         </p:nvSpPr>
         <p:spPr>
           <a:xfrm>
-            <a:off x="1861691" y="558701"/>
-            <a:ext cx="3980230" cy="474911"/>
+            <a:off x="812750" y="936278"/>
+            <a:ext cx="7969609" cy="396180"/>
           </a:xfrm>
           <a:prstGeom prst="rect">
             <a:avLst/>
@@ -5833,12 +5836,15 @@
           <a:p>
             <a:pPr algn="l" indent="0" marL="0">
               <a:lnSpc>
-                <a:spcPts val="3740"/>
+                <a:spcPts val="3120"/>
               </a:lnSpc>
-              <a:buNone/>
-            </a:pPr>
-            <a:r>
-              <a:rPr lang="en-US" sz="3400" b="1" dirty="0">
+              <a:spcAft>
+                <a:spcPts val="2400"/>
+              </a:spcAft>
+              <a:buNone/>
+            </a:pPr>
+            <a:r>
+              <a:rPr lang="en-US" sz="2600" b="1" dirty="0">
                 <a:solidFill>
                   <a:srgbClr val="1A1A1A"/>
                 </a:solidFill>
@@ -5848,7 +5854,7 @@
               </a:rPr>
               <a:t>리스크를 감수하는 판단</a:t>
             </a:r>
-            <a:endParaRPr lang="en-US" sz="3400" dirty="0"/>
+            <a:endParaRPr lang="en-US" sz="2600" dirty="0"/>
           </a:p>
         </p:txBody>
       </p:sp>
@@ -5860,7 +5866,7 @@
         </p:nvSpPr>
         <p:spPr>
           <a:xfrm>
-            <a:off x="812750" y="1389162"/>
+            <a:off x="812750" y="1637258"/>
             <a:ext cx="7518499" cy="1079599"/>
           </a:xfrm>
           <a:prstGeom prst="rect">
@@ -5890,7 +5896,7 @@
         </p:nvSpPr>
         <p:spPr>
           <a:xfrm>
-            <a:off x="836563" y="1389162"/>
+            <a:off x="836563" y="1637258"/>
             <a:ext cx="0" cy="1079599"/>
           </a:xfrm>
           <a:prstGeom prst="line">
@@ -5913,7 +5919,7 @@
         </p:nvSpPr>
         <p:spPr>
           <a:xfrm>
-            <a:off x="1165175" y="1617762"/>
+            <a:off x="1165175" y="1865858"/>
             <a:ext cx="7272951" cy="311200"/>
           </a:xfrm>
           <a:prstGeom prst="rect">
@@ -5955,7 +5961,7 @@
         </p:nvSpPr>
         <p:spPr>
           <a:xfrm>
-            <a:off x="1165175" y="1928961"/>
+            <a:off x="1165175" y="2177058"/>
             <a:ext cx="7272951" cy="311200"/>
           </a:xfrm>
           <a:prstGeom prst="rect">
@@ -5998,7 +6004,7 @@
         <p:spPr>
           <a:xfrm>
             <a:off x="812750" y="4009579"/>
-            <a:ext cx="3399996" cy="312986"/>
+            <a:ext cx="3416088" cy="312986"/>
           </a:xfrm>
           <a:prstGeom prst="rect">
             <a:avLst/>
@@ -6040,7 +6046,7 @@
         <p:spPr>
           <a:xfrm>
             <a:off x="812750" y="4322564"/>
-            <a:ext cx="3364816" cy="312986"/>
+            <a:ext cx="3383590" cy="312986"/>
           </a:xfrm>
           <a:prstGeom prst="rect">
             <a:avLst/>
@@ -6113,7 +6119,7 @@
         </p:nvSpPr>
         <p:spPr>
           <a:xfrm>
-            <a:off x="812750" y="675531"/>
+            <a:off x="812750" y="558701"/>
             <a:ext cx="848469" cy="241102"/>
           </a:xfrm>
           <a:prstGeom prst="rect">
@@ -6143,7 +6149,7 @@
         </p:nvSpPr>
         <p:spPr>
           <a:xfrm>
-            <a:off x="990451" y="738932"/>
+            <a:off x="990451" y="622102"/>
             <a:ext cx="522652" cy="114300"/>
           </a:xfrm>
           <a:prstGeom prst="rect">
@@ -6182,8 +6188,8 @@
         </p:nvSpPr>
         <p:spPr>
           <a:xfrm>
-            <a:off x="1864370" y="558701"/>
-            <a:ext cx="1990115" cy="474911"/>
+            <a:off x="812750" y="926753"/>
+            <a:ext cx="7969609" cy="396180"/>
           </a:xfrm>
           <a:prstGeom prst="rect">
             <a:avLst/>
@@ -6197,12 +6203,15 @@
           <a:p>
             <a:pPr algn="l" indent="0" marL="0">
               <a:lnSpc>
-                <a:spcPts val="3740"/>
+                <a:spcPts val="3120"/>
               </a:lnSpc>
-              <a:buNone/>
-            </a:pPr>
-            <a:r>
-              <a:rPr lang="en-US" sz="3400" b="1" dirty="0">
+              <a:spcAft>
+                <a:spcPts val="2400"/>
+              </a:spcAft>
+              <a:buNone/>
+            </a:pPr>
+            <a:r>
+              <a:rPr lang="en-US" sz="2600" b="1" dirty="0">
                 <a:solidFill>
                   <a:srgbClr val="1A1A1A"/>
                 </a:solidFill>
@@ -6212,7 +6221,7 @@
               </a:rPr>
               <a:t>버리는 판단</a:t>
             </a:r>
-            <a:endParaRPr lang="en-US" sz="3400" dirty="0"/>
+            <a:endParaRPr lang="en-US" sz="2600" dirty="0"/>
           </a:p>
         </p:txBody>
       </p:sp>
@@ -6224,7 +6233,7 @@
         </p:nvSpPr>
         <p:spPr>
           <a:xfrm>
-            <a:off x="812750" y="1389162"/>
+            <a:off x="812750" y="1627733"/>
             <a:ext cx="7518499" cy="888802"/>
           </a:xfrm>
           <a:prstGeom prst="rect">
@@ -6254,7 +6263,7 @@
         </p:nvSpPr>
         <p:spPr>
           <a:xfrm>
-            <a:off x="1168301" y="1643063"/>
+            <a:off x="1168301" y="1881634"/>
             <a:ext cx="7215842" cy="381000"/>
           </a:xfrm>
           <a:prstGeom prst="rect">

</xml_diff>

<commit_message>
WIP(lectures): adjust padding in lecture 02 skill slides for better spacing
- Reduce right padding in slide-06 left title block from 48pt to 32pt
- Narrow horizontal padding from 64pt to 44pt in slides 07, 08, 09
- Rebuild PPTX with updated slide layouts
- Update last-tool-error state
</commit_message>
<xml_diff>
--- a/lectures/02_ai_skills/AI대체불가Skills_v6_impeccable.pptx
+++ b/lectures/02_ai_skills/AI대체불가Skills_v6_impeccable.pptx
@@ -2177,7 +2177,7 @@
         </p:nvSpPr>
         <p:spPr>
           <a:xfrm>
-            <a:off x="0" y="544413"/>
+            <a:off x="0" y="553938"/>
             <a:ext cx="9144000" cy="0"/>
           </a:xfrm>
           <a:prstGeom prst="line">
@@ -2201,7 +2201,7 @@
         <p:spPr>
           <a:xfrm>
             <a:off x="660350" y="203150"/>
-            <a:ext cx="8292697" cy="133350"/>
+            <a:ext cx="8292697" cy="142875"/>
           </a:xfrm>
           <a:prstGeom prst="rect">
             <a:avLst/>
@@ -2239,8 +2239,8 @@
         </p:nvSpPr>
         <p:spPr>
           <a:xfrm>
-            <a:off x="0" y="549176"/>
-            <a:ext cx="3403550" cy="4594324"/>
+            <a:off x="0" y="558701"/>
+            <a:ext cx="3403550" cy="4584799"/>
           </a:xfrm>
           <a:prstGeom prst="rect">
             <a:avLst/>
@@ -2269,8 +2269,8 @@
         </p:nvSpPr>
         <p:spPr>
           <a:xfrm>
-            <a:off x="3398788" y="549176"/>
-            <a:ext cx="0" cy="4594324"/>
+            <a:off x="3398788" y="558701"/>
+            <a:ext cx="0" cy="4584799"/>
           </a:xfrm>
           <a:prstGeom prst="line">
             <a:avLst/>
@@ -2292,8 +2292,8 @@
         </p:nvSpPr>
         <p:spPr>
           <a:xfrm>
-            <a:off x="406301" y="904726"/>
-            <a:ext cx="2736309" cy="123825"/>
+            <a:off x="406301" y="914251"/>
+            <a:ext cx="2736309" cy="114300"/>
           </a:xfrm>
           <a:prstGeom prst="rect">
             <a:avLst/>
@@ -2448,8 +2448,8 @@
         </p:nvSpPr>
         <p:spPr>
           <a:xfrm>
-            <a:off x="3403550" y="549176"/>
-            <a:ext cx="5740450" cy="4594324"/>
+            <a:off x="3403550" y="558701"/>
+            <a:ext cx="5740450" cy="4584799"/>
           </a:xfrm>
           <a:prstGeom prst="rect">
             <a:avLst/>
@@ -2478,8 +2478,8 @@
         </p:nvSpPr>
         <p:spPr>
           <a:xfrm>
-            <a:off x="3422600" y="549176"/>
-            <a:ext cx="0" cy="4594324"/>
+            <a:off x="3422600" y="558701"/>
+            <a:ext cx="0" cy="4584799"/>
           </a:xfrm>
           <a:prstGeom prst="line">
             <a:avLst/>
@@ -2501,8 +2501,8 @@
         </p:nvSpPr>
         <p:spPr>
           <a:xfrm>
-            <a:off x="3949601" y="2082850"/>
-            <a:ext cx="4967636" cy="123825"/>
+            <a:off x="3949601" y="2092375"/>
+            <a:ext cx="4967636" cy="114300"/>
           </a:xfrm>
           <a:prstGeom prst="rect">
             <a:avLst/>
@@ -2732,7 +2732,7 @@
         <p:spPr>
           <a:xfrm>
             <a:off x="914400" y="558701"/>
-            <a:ext cx="7754112" cy="123825"/>
+            <a:ext cx="7754112" cy="114300"/>
           </a:xfrm>
           <a:prstGeom prst="rect">
             <a:avLst/>
@@ -2773,8 +2773,8 @@
         </p:nvSpPr>
         <p:spPr>
           <a:xfrm>
-            <a:off x="914400" y="834926"/>
-            <a:ext cx="1053980" cy="219075"/>
+            <a:off x="914400" y="825401"/>
+            <a:ext cx="1054926" cy="209550"/>
           </a:xfrm>
           <a:prstGeom prst="rect">
             <a:avLst/>
@@ -2812,8 +2812,8 @@
         </p:nvSpPr>
         <p:spPr>
           <a:xfrm>
-            <a:off x="1908721" y="834926"/>
-            <a:ext cx="369311" cy="219075"/>
+            <a:off x="1909614" y="825401"/>
+            <a:ext cx="372466" cy="209550"/>
           </a:xfrm>
           <a:prstGeom prst="rect">
             <a:avLst/>
@@ -2851,8 +2851,8 @@
         </p:nvSpPr>
         <p:spPr>
           <a:xfrm>
-            <a:off x="2257127" y="834926"/>
-            <a:ext cx="1536719" cy="219075"/>
+            <a:off x="2260997" y="825401"/>
+            <a:ext cx="1538139" cy="209550"/>
           </a:xfrm>
           <a:prstGeom prst="rect">
             <a:avLst/>
@@ -2890,8 +2890,8 @@
         </p:nvSpPr>
         <p:spPr>
           <a:xfrm>
-            <a:off x="3706862" y="834926"/>
-            <a:ext cx="369311" cy="219075"/>
+            <a:off x="3712071" y="825401"/>
+            <a:ext cx="372466" cy="209550"/>
           </a:xfrm>
           <a:prstGeom prst="rect">
             <a:avLst/>
@@ -2929,8 +2929,8 @@
         </p:nvSpPr>
         <p:spPr>
           <a:xfrm>
-            <a:off x="4055269" y="834926"/>
-            <a:ext cx="1214893" cy="219075"/>
+            <a:off x="4063454" y="825401"/>
+            <a:ext cx="1215997" cy="209550"/>
           </a:xfrm>
           <a:prstGeom prst="rect">
             <a:avLst/>
@@ -2968,7 +2968,7 @@
         </p:nvSpPr>
         <p:spPr>
           <a:xfrm>
-            <a:off x="914400" y="1921966"/>
+            <a:off x="914400" y="1917204"/>
             <a:ext cx="7315200" cy="12650"/>
           </a:xfrm>
           <a:prstGeom prst="rect">
@@ -2998,8 +2998,8 @@
         </p:nvSpPr>
         <p:spPr>
           <a:xfrm>
-            <a:off x="914400" y="2802582"/>
-            <a:ext cx="1023045" cy="225326"/>
+            <a:off x="914400" y="2812107"/>
+            <a:ext cx="1062038" cy="215801"/>
           </a:xfrm>
           <a:prstGeom prst="rect">
             <a:avLst/>
@@ -3028,8 +3028,8 @@
         </p:nvSpPr>
         <p:spPr>
           <a:xfrm>
-            <a:off x="1066800" y="2853333"/>
-            <a:ext cx="761339" cy="123825"/>
+            <a:off x="1066800" y="2862858"/>
+            <a:ext cx="802672" cy="114300"/>
           </a:xfrm>
           <a:prstGeom prst="rect">
             <a:avLst/>
@@ -3498,8 +3498,8 @@
         </p:nvSpPr>
         <p:spPr>
           <a:xfrm>
-            <a:off x="1091952" y="601563"/>
-            <a:ext cx="948913" cy="123825"/>
+            <a:off x="1091952" y="611088"/>
+            <a:ext cx="996083" cy="114300"/>
           </a:xfrm>
           <a:prstGeom prst="rect">
             <a:avLst/>
@@ -3541,7 +3541,7 @@
         <p:spPr>
           <a:xfrm>
             <a:off x="1091952" y="750689"/>
-            <a:ext cx="948913" cy="171450"/>
+            <a:ext cx="996083" cy="161925"/>
           </a:xfrm>
           <a:prstGeom prst="rect">
             <a:avLst/>
@@ -3705,8 +3705,8 @@
         </p:nvSpPr>
         <p:spPr>
           <a:xfrm>
-            <a:off x="3352651" y="1577132"/>
-            <a:ext cx="5492654" cy="171450"/>
+            <a:off x="3352651" y="1581894"/>
+            <a:ext cx="5492654" cy="161925"/>
           </a:xfrm>
           <a:prstGeom prst="rect">
             <a:avLst/>
@@ -3747,7 +3747,7 @@
         </p:nvSpPr>
         <p:spPr>
           <a:xfrm>
-            <a:off x="3352651" y="1900982"/>
+            <a:off x="3352651" y="1896219"/>
             <a:ext cx="5492654" cy="554980"/>
           </a:xfrm>
           <a:prstGeom prst="rect">
@@ -3789,7 +3789,7 @@
         </p:nvSpPr>
         <p:spPr>
           <a:xfrm>
-            <a:off x="3352651" y="2455962"/>
+            <a:off x="3352651" y="2451199"/>
             <a:ext cx="5492654" cy="554980"/>
           </a:xfrm>
           <a:prstGeom prst="rect">
@@ -4296,8 +4296,8 @@
         </p:nvSpPr>
         <p:spPr>
           <a:xfrm>
-            <a:off x="1092101" y="639663"/>
-            <a:ext cx="1307812" cy="142875"/>
+            <a:off x="1092101" y="644426"/>
+            <a:ext cx="1244078" cy="133350"/>
           </a:xfrm>
           <a:prstGeom prst="rect">
             <a:avLst/>
@@ -4484,8 +4484,8 @@
         </p:nvSpPr>
         <p:spPr>
           <a:xfrm>
-            <a:off x="5181600" y="730746"/>
-            <a:ext cx="3553968" cy="142875"/>
+            <a:off x="5181600" y="711696"/>
+            <a:ext cx="3553968" cy="133350"/>
           </a:xfrm>
           <a:prstGeom prst="rect">
             <a:avLst/>
@@ -4526,8 +4526,8 @@
         </p:nvSpPr>
         <p:spPr>
           <a:xfrm>
-            <a:off x="5181600" y="1178421"/>
-            <a:ext cx="3352800" cy="752177"/>
+            <a:off x="5181600" y="1149846"/>
+            <a:ext cx="3352800" cy="761702"/>
           </a:xfrm>
           <a:prstGeom prst="rect">
             <a:avLst/>
@@ -4556,8 +4556,8 @@
         </p:nvSpPr>
         <p:spPr>
           <a:xfrm>
-            <a:off x="5435501" y="1356122"/>
-            <a:ext cx="3015698" cy="219075"/>
+            <a:off x="5435501" y="1327547"/>
+            <a:ext cx="3015698" cy="228600"/>
           </a:xfrm>
           <a:prstGeom prst="rect">
             <a:avLst/>
@@ -4595,7 +4595,7 @@
         </p:nvSpPr>
         <p:spPr>
           <a:xfrm>
-            <a:off x="5435501" y="1600498"/>
+            <a:off x="5435501" y="1581448"/>
             <a:ext cx="3015698" cy="152400"/>
           </a:xfrm>
           <a:prstGeom prst="rect">
@@ -4637,8 +4637,8 @@
         </p:nvSpPr>
         <p:spPr>
           <a:xfrm>
-            <a:off x="5435501" y="2057549"/>
-            <a:ext cx="3015698" cy="323850"/>
+            <a:off x="5435501" y="2038499"/>
+            <a:ext cx="3015698" cy="333375"/>
           </a:xfrm>
           <a:prstGeom prst="rect">
             <a:avLst/>
@@ -4676,8 +4676,8 @@
         </p:nvSpPr>
         <p:spPr>
           <a:xfrm>
-            <a:off x="5181600" y="2508349"/>
-            <a:ext cx="3352800" cy="752177"/>
+            <a:off x="5181600" y="2498824"/>
+            <a:ext cx="3352800" cy="761702"/>
           </a:xfrm>
           <a:prstGeom prst="rect">
             <a:avLst/>
@@ -4706,8 +4706,8 @@
         </p:nvSpPr>
         <p:spPr>
           <a:xfrm>
-            <a:off x="5435501" y="2686050"/>
-            <a:ext cx="3015698" cy="219075"/>
+            <a:off x="5435501" y="2676525"/>
+            <a:ext cx="3015698" cy="228600"/>
           </a:xfrm>
           <a:prstGeom prst="rect">
             <a:avLst/>
@@ -4788,7 +4788,7 @@
         <p:spPr>
           <a:xfrm>
             <a:off x="5435501" y="3387477"/>
-            <a:ext cx="3015698" cy="323850"/>
+            <a:ext cx="3015698" cy="333375"/>
           </a:xfrm>
           <a:prstGeom prst="rect">
             <a:avLst/>
@@ -4826,8 +4826,8 @@
         </p:nvSpPr>
         <p:spPr>
           <a:xfrm>
-            <a:off x="5181600" y="3838277"/>
-            <a:ext cx="3352800" cy="574477"/>
+            <a:off x="5181600" y="3847802"/>
+            <a:ext cx="3352800" cy="584002"/>
           </a:xfrm>
           <a:prstGeom prst="rect">
             <a:avLst/>
@@ -4856,8 +4856,8 @@
         </p:nvSpPr>
         <p:spPr>
           <a:xfrm>
-            <a:off x="5435501" y="4015978"/>
-            <a:ext cx="3015698" cy="219075"/>
+            <a:off x="5435501" y="4025503"/>
+            <a:ext cx="3015698" cy="228600"/>
           </a:xfrm>
           <a:prstGeom prst="rect">
             <a:avLst/>
@@ -4951,7 +4951,7 @@
         <p:spPr>
           <a:xfrm>
             <a:off x="812750" y="660350"/>
-            <a:ext cx="3732392" cy="114300"/>
+            <a:ext cx="3947889" cy="114300"/>
           </a:xfrm>
           <a:prstGeom prst="rect">
             <a:avLst/>
@@ -4993,7 +4993,7 @@
         <p:spPr>
           <a:xfrm>
             <a:off x="812750" y="1079450"/>
-            <a:ext cx="3732392" cy="518071"/>
+            <a:ext cx="3947889" cy="518071"/>
           </a:xfrm>
           <a:prstGeom prst="rect">
             <a:avLst/>
@@ -5035,7 +5035,7 @@
         <p:spPr>
           <a:xfrm>
             <a:off x="812750" y="1597521"/>
-            <a:ext cx="3732392" cy="518071"/>
+            <a:ext cx="3947889" cy="518071"/>
           </a:xfrm>
           <a:prstGeom prst="rect">
             <a:avLst/>
@@ -5427,7 +5427,7 @@
         </p:nvSpPr>
         <p:spPr>
           <a:xfrm>
-            <a:off x="812750" y="558701"/>
+            <a:off x="558701" y="558701"/>
             <a:ext cx="832396" cy="241102"/>
           </a:xfrm>
           <a:prstGeom prst="rect">
@@ -5457,7 +5457,7 @@
         </p:nvSpPr>
         <p:spPr>
           <a:xfrm>
-            <a:off x="990451" y="622102"/>
+            <a:off x="736402" y="622102"/>
             <a:ext cx="505614" cy="114300"/>
           </a:xfrm>
           <a:prstGeom prst="rect">
@@ -5496,8 +5496,8 @@
         </p:nvSpPr>
         <p:spPr>
           <a:xfrm>
-            <a:off x="812750" y="926753"/>
-            <a:ext cx="7969609" cy="396180"/>
+            <a:off x="558701" y="926753"/>
+            <a:ext cx="8508194" cy="396180"/>
           </a:xfrm>
           <a:prstGeom prst="rect">
             <a:avLst/>
@@ -5541,8 +5541,8 @@
         </p:nvSpPr>
         <p:spPr>
           <a:xfrm>
-            <a:off x="812750" y="1627733"/>
-            <a:ext cx="7518499" cy="1079599"/>
+            <a:off x="558701" y="1627733"/>
+            <a:ext cx="8026598" cy="1079599"/>
           </a:xfrm>
           <a:prstGeom prst="rect">
             <a:avLst/>
@@ -5571,7 +5571,7 @@
         </p:nvSpPr>
         <p:spPr>
           <a:xfrm>
-            <a:off x="836563" y="1627733"/>
+            <a:off x="582513" y="1627733"/>
             <a:ext cx="0" cy="1079599"/>
           </a:xfrm>
           <a:prstGeom prst="line">
@@ -5594,8 +5594,8 @@
         </p:nvSpPr>
         <p:spPr>
           <a:xfrm>
-            <a:off x="1165175" y="1856333"/>
-            <a:ext cx="7272951" cy="311200"/>
+            <a:off x="911126" y="1856333"/>
+            <a:ext cx="7811536" cy="311200"/>
           </a:xfrm>
           <a:prstGeom prst="rect">
             <a:avLst/>
@@ -5636,8 +5636,8 @@
         </p:nvSpPr>
         <p:spPr>
           <a:xfrm>
-            <a:off x="1165175" y="2167533"/>
-            <a:ext cx="7272951" cy="311200"/>
+            <a:off x="911126" y="2167533"/>
+            <a:ext cx="7811536" cy="311200"/>
           </a:xfrm>
           <a:prstGeom prst="rect">
             <a:avLst/>
@@ -5678,7 +5678,7 @@
         </p:nvSpPr>
         <p:spPr>
           <a:xfrm>
-            <a:off x="812750" y="4315569"/>
+            <a:off x="558701" y="4315569"/>
             <a:ext cx="4806092" cy="319980"/>
           </a:xfrm>
           <a:prstGeom prst="rect">
@@ -5752,8 +5752,8 @@
         </p:nvSpPr>
         <p:spPr>
           <a:xfrm>
-            <a:off x="812750" y="558701"/>
-            <a:ext cx="809476" cy="250627"/>
+            <a:off x="558701" y="558701"/>
+            <a:ext cx="845790" cy="241102"/>
           </a:xfrm>
           <a:prstGeom prst="rect">
             <a:avLst/>
@@ -5782,8 +5782,8 @@
         </p:nvSpPr>
         <p:spPr>
           <a:xfrm>
-            <a:off x="990451" y="622102"/>
-            <a:ext cx="481319" cy="123825"/>
+            <a:off x="736402" y="622102"/>
+            <a:ext cx="519812" cy="114300"/>
           </a:xfrm>
           <a:prstGeom prst="rect">
             <a:avLst/>
@@ -5821,8 +5821,8 @@
         </p:nvSpPr>
         <p:spPr>
           <a:xfrm>
-            <a:off x="812750" y="936278"/>
-            <a:ext cx="7969609" cy="396180"/>
+            <a:off x="558701" y="926753"/>
+            <a:ext cx="8508194" cy="396180"/>
           </a:xfrm>
           <a:prstGeom prst="rect">
             <a:avLst/>
@@ -5866,8 +5866,8 @@
         </p:nvSpPr>
         <p:spPr>
           <a:xfrm>
-            <a:off x="812750" y="1637258"/>
-            <a:ext cx="7518499" cy="1079599"/>
+            <a:off x="558701" y="1627733"/>
+            <a:ext cx="8026598" cy="1079599"/>
           </a:xfrm>
           <a:prstGeom prst="rect">
             <a:avLst/>
@@ -5896,7 +5896,7 @@
         </p:nvSpPr>
         <p:spPr>
           <a:xfrm>
-            <a:off x="836563" y="1637258"/>
+            <a:off x="582513" y="1627733"/>
             <a:ext cx="0" cy="1079599"/>
           </a:xfrm>
           <a:prstGeom prst="line">
@@ -5919,8 +5919,8 @@
         </p:nvSpPr>
         <p:spPr>
           <a:xfrm>
-            <a:off x="1165175" y="1865858"/>
-            <a:ext cx="7272951" cy="311200"/>
+            <a:off x="911126" y="1856333"/>
+            <a:ext cx="7811536" cy="311200"/>
           </a:xfrm>
           <a:prstGeom prst="rect">
             <a:avLst/>
@@ -5961,8 +5961,8 @@
         </p:nvSpPr>
         <p:spPr>
           <a:xfrm>
-            <a:off x="1165175" y="2177058"/>
-            <a:ext cx="7272951" cy="311200"/>
+            <a:off x="911126" y="2167533"/>
+            <a:ext cx="7811536" cy="311200"/>
           </a:xfrm>
           <a:prstGeom prst="rect">
             <a:avLst/>
@@ -6003,8 +6003,8 @@
         </p:nvSpPr>
         <p:spPr>
           <a:xfrm>
-            <a:off x="812750" y="4009579"/>
-            <a:ext cx="3416088" cy="312986"/>
+            <a:off x="558701" y="4009579"/>
+            <a:ext cx="3399996" cy="312986"/>
           </a:xfrm>
           <a:prstGeom prst="rect">
             <a:avLst/>
@@ -6045,8 +6045,8 @@
         </p:nvSpPr>
         <p:spPr>
           <a:xfrm>
-            <a:off x="812750" y="4322564"/>
-            <a:ext cx="3383590" cy="312986"/>
+            <a:off x="558701" y="4322564"/>
+            <a:ext cx="3364816" cy="312986"/>
           </a:xfrm>
           <a:prstGeom prst="rect">
             <a:avLst/>
@@ -6119,8 +6119,8 @@
         </p:nvSpPr>
         <p:spPr>
           <a:xfrm>
-            <a:off x="812750" y="558701"/>
-            <a:ext cx="848469" cy="241102"/>
+            <a:off x="558701" y="558701"/>
+            <a:ext cx="812453" cy="250627"/>
           </a:xfrm>
           <a:prstGeom prst="rect">
             <a:avLst/>
@@ -6149,8 +6149,8 @@
         </p:nvSpPr>
         <p:spPr>
           <a:xfrm>
-            <a:off x="990451" y="622102"/>
-            <a:ext cx="522652" cy="114300"/>
+            <a:off x="736402" y="622102"/>
+            <a:ext cx="484474" cy="123825"/>
           </a:xfrm>
           <a:prstGeom prst="rect">
             <a:avLst/>
@@ -6188,8 +6188,8 @@
         </p:nvSpPr>
         <p:spPr>
           <a:xfrm>
-            <a:off x="812750" y="926753"/>
-            <a:ext cx="7969609" cy="396180"/>
+            <a:off x="558701" y="936278"/>
+            <a:ext cx="8508194" cy="396180"/>
           </a:xfrm>
           <a:prstGeom prst="rect">
             <a:avLst/>
@@ -6233,8 +6233,8 @@
         </p:nvSpPr>
         <p:spPr>
           <a:xfrm>
-            <a:off x="812750" y="1627733"/>
-            <a:ext cx="7518499" cy="888802"/>
+            <a:off x="558701" y="1637258"/>
+            <a:ext cx="8026598" cy="888802"/>
           </a:xfrm>
           <a:prstGeom prst="rect">
             <a:avLst/>
@@ -6263,8 +6263,8 @@
         </p:nvSpPr>
         <p:spPr>
           <a:xfrm>
-            <a:off x="1168301" y="1881634"/>
-            <a:ext cx="7215842" cy="381000"/>
+            <a:off x="914251" y="1891159"/>
+            <a:ext cx="7754428" cy="381000"/>
           </a:xfrm>
           <a:prstGeom prst="rect">
             <a:avLst/>
@@ -6305,8 +6305,8 @@
         </p:nvSpPr>
         <p:spPr>
           <a:xfrm>
-            <a:off x="812750" y="4006007"/>
-            <a:ext cx="2714854" cy="314771"/>
+            <a:off x="558701" y="4006007"/>
+            <a:ext cx="2722584" cy="314771"/>
           </a:xfrm>
           <a:prstGeom prst="rect">
             <a:avLst/>
@@ -6347,8 +6347,8 @@
         </p:nvSpPr>
         <p:spPr>
           <a:xfrm>
-            <a:off x="812750" y="4320778"/>
-            <a:ext cx="2714854" cy="314771"/>
+            <a:off x="558701" y="4320778"/>
+            <a:ext cx="2722584" cy="314771"/>
           </a:xfrm>
           <a:prstGeom prst="rect">
             <a:avLst/>

</xml_diff>